<commit_message>
Add full team photo and names to presentation
</commit_message>
<xml_diff>
--- a/Student-Record-API-Presentation.pptx
+++ b/Student-Record-API-Presentation.pptx
@@ -13,9 +13,10 @@
     <p:sldId id="261" r:id="rId7"/>
     <p:sldId id="262" r:id="rId8"/>
     <p:sldId id="263" r:id="rId9"/>
+    <p:sldId id="264" r:id="rId10"/>
   </p:sldIdLst>
   <p:notesMasterIdLst>
-    <p:notesMasterId r:id="rId10"/>
+    <p:notesMasterId r:id="rId11"/>
   </p:notesMasterIdLst>
   <p:sldSz cx="12192000" cy="6858000"/>
   <p:notesSz cx="6858000" cy="12192000"/>
@@ -1167,6 +1168,94 @@
 </p:notes>
 </file>
 
+<file path=ppt/notesSlides/notesSlide9.xml><?xml version="1.0" encoding="utf-8"?>
+<p:notes xmlns:a="http://schemas.openxmlformats.org/drawingml/2006/main" xmlns:r="http://schemas.openxmlformats.org/officeDocument/2006/relationships" xmlns:p="http://schemas.openxmlformats.org/presentationml/2006/main">
+  <p:cSld>
+    <p:spTree>
+      <p:nvGrpSpPr>
+        <p:cNvPr id="1" name=""/>
+        <p:cNvGrpSpPr/>
+        <p:nvPr/>
+      </p:nvGrpSpPr>
+      <p:grpSpPr>
+        <a:xfrm>
+          <a:off x="0" y="0"/>
+          <a:ext cx="0" cy="0"/>
+          <a:chOff x="0" y="0"/>
+          <a:chExt cx="0" cy="0"/>
+        </a:xfrm>
+      </p:grpSpPr>
+      <p:sp>
+        <p:nvSpPr>
+          <p:cNvPr id="2" name="Slide Image Placeholder 1"/>
+          <p:cNvSpPr>
+            <a:spLocks noGrp="1" noRot="1" noChangeAspect="1"/>
+          </p:cNvSpPr>
+          <p:nvPr>
+            <p:ph type="sldImg"/>
+          </p:nvPr>
+        </p:nvSpPr>
+        <p:spPr/>
+      </p:sp>
+      <p:sp>
+        <p:nvSpPr>
+          <p:cNvPr id="3" name="Notes Placeholder 2"/>
+          <p:cNvSpPr>
+            <a:spLocks noGrp="1"/>
+          </p:cNvSpPr>
+          <p:nvPr>
+            <p:ph type="body" idx="1"/>
+          </p:nvPr>
+        </p:nvSpPr>
+        <p:spPr/>
+        <p:txBody>
+          <a:bodyPr/>
+          <a:lstStyle/>
+          <a:p>
+            <a:r>
+              <a:rPr lang="en-US" dirty="0"/>
+              <a:t/>
+            </a:r>
+            <a:endParaRPr lang="en-US" dirty="0"/>
+          </a:p>
+        </p:txBody>
+      </p:sp>
+      <p:sp>
+        <p:nvSpPr>
+          <p:cNvPr id="4" name="Slide Number Placeholder 3"/>
+          <p:cNvSpPr>
+            <a:spLocks noGrp="1"/>
+          </p:cNvSpPr>
+          <p:nvPr>
+            <p:ph type="sldNum" sz="quarter" idx="10"/>
+          </p:nvPr>
+        </p:nvSpPr>
+        <p:spPr/>
+        <p:txBody>
+          <a:bodyPr/>
+          <a:lstStyle/>
+          <a:p>
+            <a:fld id="{F7021451-1387-4CA6-816F-3879F97B5CBC}" type="slidenum">
+              <a:rPr lang="en-US"/>
+              <a:t>9</a:t>
+            </a:fld>
+            <a:endParaRPr lang="en-US"/>
+          </a:p>
+        </p:txBody>
+      </p:sp>
+    </p:spTree>
+    <p:extLst>
+      <p:ext uri="{BB962C8B-B14F-4D97-AF65-F5344CB8AC3E}">
+        <p14:creationId xmlns:p14="http://schemas.microsoft.com/office/powerpoint/2010/main" val="1024086991"/>
+      </p:ext>
+    </p:extLst>
+  </p:cSld>
+  <p:clrMapOvr>
+    <a:masterClrMapping/>
+  </p:clrMapOvr>
+</p:notes>
+</file>
+
 <file path=ppt/slideLayouts/slideLayout1.xml><?xml version="1.0" encoding="utf-8"?>
 <p:sldLayout xmlns:a="http://schemas.openxmlformats.org/drawingml/2006/main" xmlns:r="http://schemas.openxmlformats.org/officeDocument/2006/relationships" xmlns:p="http://schemas.openxmlformats.org/presentationml/2006/main" preserve="1">
   <p:cSld name="DEFAULT">
@@ -1732,6 +1821,247 @@
     <p:bg>
       <p:bgPr>
         <a:solidFill>
+          <a:srgbClr val="FFFFFF"/>
+        </a:solidFill>
+      </p:bgPr>
+    </p:bg>
+    <p:spTree>
+      <p:nvGrpSpPr>
+        <p:cNvPr id="1" name=""/>
+        <p:cNvGrpSpPr/>
+        <p:nvPr/>
+      </p:nvGrpSpPr>
+      <p:grpSpPr>
+        <a:xfrm>
+          <a:off x="0" y="0"/>
+          <a:ext cx="0" cy="0"/>
+          <a:chOff x="0" y="0"/>
+          <a:chExt cx="0" cy="0"/>
+        </a:xfrm>
+      </p:grpSpPr>
+      <p:sp>
+        <p:nvSpPr>
+          <p:cNvPr id="2" name="Text 0"/>
+          <p:cNvSpPr/>
+          <p:nvPr/>
+        </p:nvSpPr>
+        <p:spPr>
+          <a:xfrm>
+            <a:off x="640080" y="411480"/>
+            <a:ext cx="10058400" cy="640080"/>
+          </a:xfrm>
+          <a:prstGeom prst="rect">
+            <a:avLst/>
+          </a:prstGeom>
+          <a:noFill/>
+          <a:ln/>
+        </p:spPr>
+        <p:txBody>
+          <a:bodyPr wrap="square" rtlCol="0" anchor="ctr"/>
+          <a:lstStyle/>
+          <a:p>
+            <a:pPr indent="0" marL="0">
+              <a:buNone/>
+            </a:pPr>
+            <a:r>
+              <a:rPr lang="en-US" sz="3000" b="1" dirty="0">
+                <a:solidFill>
+                  <a:srgbClr val="1B2A4A"/>
+                </a:solidFill>
+                <a:latin typeface="Georgia" pitchFamily="34" charset="0"/>
+                <a:ea typeface="Georgia" pitchFamily="34" charset="-122"/>
+                <a:cs typeface="Georgia" pitchFamily="34" charset="-120"/>
+              </a:rPr>
+              <a:t>Our Team</a:t>
+            </a:r>
+            <a:endParaRPr lang="en-US" sz="3000" dirty="0"/>
+          </a:p>
+        </p:txBody>
+      </p:sp>
+      <p:sp>
+        <p:nvSpPr>
+          <p:cNvPr id="3" name="Text 1"/>
+          <p:cNvSpPr/>
+          <p:nvPr/>
+        </p:nvSpPr>
+        <p:spPr>
+          <a:xfrm>
+            <a:off x="640080" y="1005840"/>
+            <a:ext cx="10058400" cy="365760"/>
+          </a:xfrm>
+          <a:prstGeom prst="rect">
+            <a:avLst/>
+          </a:prstGeom>
+          <a:noFill/>
+          <a:ln/>
+        </p:spPr>
+        <p:txBody>
+          <a:bodyPr wrap="square" rtlCol="0" anchor="ctr"/>
+          <a:lstStyle/>
+          <a:p>
+            <a:pPr indent="0" marL="0">
+              <a:buNone/>
+            </a:pPr>
+            <a:r>
+              <a:rPr lang="en-US" sz="1300" dirty="0">
+                <a:solidFill>
+                  <a:srgbClr val="4A5568"/>
+                </a:solidFill>
+                <a:latin typeface="Calibri" pitchFamily="34" charset="0"/>
+                <a:ea typeface="Calibri" pitchFamily="34" charset="-122"/>
+                <a:cs typeface="Calibri" pitchFamily="34" charset="-120"/>
+              </a:rPr>
+              <a:t>BeTechified July 2026 Cohort — Backend Development, Group 2</a:t>
+            </a:r>
+            <a:endParaRPr lang="en-US" sz="1300" dirty="0"/>
+          </a:p>
+        </p:txBody>
+      </p:sp>
+      <p:sp>
+        <p:nvSpPr>
+          <p:cNvPr id="4" name="Shape 2"/>
+          <p:cNvSpPr/>
+          <p:nvPr/>
+        </p:nvSpPr>
+        <p:spPr>
+          <a:xfrm>
+            <a:off x="3534730" y="1435608"/>
+            <a:ext cx="5119491" cy="4992624"/>
+          </a:xfrm>
+          <a:prstGeom prst="roundRect">
+            <a:avLst>
+              <a:gd name="adj" fmla="val 1465"/>
+            </a:avLst>
+          </a:prstGeom>
+          <a:solidFill>
+            <a:srgbClr val="FFFFFF"/>
+          </a:solidFill>
+          <a:ln/>
+          <a:effectLst>
+            <a:outerShdw sx="100000" sy="100000" kx="0" ky="0" algn="bl" rotWithShape="0" blurRad="127000" dist="38100" dir="5400000">
+              <a:srgbClr val="000000">
+                <a:alpha val="15000"/>
+              </a:srgbClr>
+            </a:outerShdw>
+          </a:effectLst>
+        </p:spPr>
+      </p:sp>
+      <p:pic>
+        <p:nvPicPr>
+          <p:cNvPr id="5" name="Image 0" descr="team-photo.png">    </p:cNvPr>
+          <p:cNvPicPr>
+            <a:picLocks noChangeAspect="1"/>
+          </p:cNvPicPr>
+          <p:nvPr/>
+        </p:nvPicPr>
+        <p:blipFill>
+          <a:blip r:embed="rId1"/>
+          <a:stretch>
+            <a:fillRect/>
+          </a:stretch>
+        </p:blipFill>
+        <p:spPr>
+          <a:xfrm>
+            <a:off x="3607882" y="1508760"/>
+            <a:ext cx="4973187" cy="4846320"/>
+          </a:xfrm>
+          <a:prstGeom prst="rect">
+            <a:avLst/>
+          </a:prstGeom>
+        </p:spPr>
+      </p:pic>
+      <p:sp>
+        <p:nvSpPr>
+          <p:cNvPr id="6" name="Text 3"/>
+          <p:cNvSpPr/>
+          <p:nvPr/>
+        </p:nvSpPr>
+        <p:spPr>
+          <a:xfrm>
+            <a:off x="457200" y="6537960"/>
+            <a:ext cx="3657600" cy="274320"/>
+          </a:xfrm>
+          <a:prstGeom prst="rect">
+            <a:avLst/>
+          </a:prstGeom>
+          <a:noFill/>
+          <a:ln/>
+        </p:spPr>
+        <p:txBody>
+          <a:bodyPr wrap="square" rtlCol="0" anchor="ctr"/>
+          <a:lstStyle/>
+          <a:p>
+            <a:pPr indent="0" marL="0">
+              <a:buNone/>
+            </a:pPr>
+            <a:r>
+              <a:rPr lang="en-US" sz="900" dirty="0">
+                <a:solidFill>
+                  <a:srgbClr val="A0AEC0"/>
+                </a:solidFill>
+                <a:latin typeface="Calibri" pitchFamily="34" charset="0"/>
+                <a:ea typeface="Calibri" pitchFamily="34" charset="-122"/>
+                <a:cs typeface="Calibri" pitchFamily="34" charset="-120"/>
+              </a:rPr>
+              <a:t>Student Record API</a:t>
+            </a:r>
+            <a:endParaRPr lang="en-US" sz="900" dirty="0"/>
+          </a:p>
+        </p:txBody>
+      </p:sp>
+      <p:sp>
+        <p:nvSpPr>
+          <p:cNvPr id="7" name="Text 4"/>
+          <p:cNvSpPr/>
+          <p:nvPr/>
+        </p:nvSpPr>
+        <p:spPr>
+          <a:xfrm>
+            <a:off x="11430000" y="6537960"/>
+            <a:ext cx="365760" cy="274320"/>
+          </a:xfrm>
+          <a:prstGeom prst="rect">
+            <a:avLst/>
+          </a:prstGeom>
+          <a:noFill/>
+          <a:ln/>
+        </p:spPr>
+        <p:txBody>
+          <a:bodyPr wrap="square" rtlCol="0" anchor="ctr"/>
+          <a:lstStyle/>
+          <a:p>
+            <a:pPr algn="r" indent="0" marL="0">
+              <a:buNone/>
+            </a:pPr>
+            <a:r>
+              <a:rPr lang="en-US" sz="900" dirty="0">
+                <a:solidFill>
+                  <a:srgbClr val="A0AEC0"/>
+                </a:solidFill>
+                <a:latin typeface="Calibri" pitchFamily="34" charset="0"/>
+                <a:ea typeface="Calibri" pitchFamily="34" charset="-122"/>
+                <a:cs typeface="Calibri" pitchFamily="34" charset="-120"/>
+              </a:rPr>
+              <a:t>2</a:t>
+            </a:r>
+            <a:endParaRPr lang="en-US" sz="900" dirty="0"/>
+          </a:p>
+        </p:txBody>
+      </p:sp>
+    </p:spTree>
+  </p:cSld>
+  <p:clrMapOvr>
+    <a:masterClrMapping/>
+  </p:clrMapOvr>
+</p:sld>
+</file>
+
+<file path=ppt/slides/slide3.xml><?xml version="1.0" encoding="utf-8"?>
+<p:sld xmlns:a="http://schemas.openxmlformats.org/drawingml/2006/main" xmlns:r="http://schemas.openxmlformats.org/officeDocument/2006/relationships" xmlns:p="http://schemas.openxmlformats.org/presentationml/2006/main">
+  <p:cSld name="Slide 3">
+    <p:bg>
+      <p:bgPr>
+        <a:solidFill>
           <a:srgbClr val="F7F9FA"/>
         </a:solidFill>
       </p:bgPr>
@@ -2587,7 +2917,7 @@
                 <a:ea typeface="Calibri" pitchFamily="34" charset="-122"/>
                 <a:cs typeface="Calibri" pitchFamily="34" charset="-120"/>
               </a:rPr>
-              <a:t>2</a:t>
+              <a:t>3</a:t>
             </a:r>
             <a:endParaRPr lang="en-US" sz="900" dirty="0"/>
           </a:p>
@@ -2601,9 +2931,9 @@
 </p:sld>
 </file>
 
-<file path=ppt/slides/slide3.xml><?xml version="1.0" encoding="utf-8"?>
+<file path=ppt/slides/slide4.xml><?xml version="1.0" encoding="utf-8"?>
 <p:sld xmlns:a="http://schemas.openxmlformats.org/drawingml/2006/main" xmlns:r="http://schemas.openxmlformats.org/officeDocument/2006/relationships" xmlns:p="http://schemas.openxmlformats.org/presentationml/2006/main">
-  <p:cSld name="Slide 3">
+  <p:cSld name="Slide 4">
     <p:bg>
       <p:bgPr>
         <a:solidFill>
@@ -3580,7 +3910,7 @@
                 <a:ea typeface="Calibri" pitchFamily="34" charset="-122"/>
                 <a:cs typeface="Calibri" pitchFamily="34" charset="-120"/>
               </a:rPr>
-              <a:t>3</a:t>
+              <a:t>4</a:t>
             </a:r>
             <a:endParaRPr lang="en-US" sz="900" dirty="0"/>
           </a:p>
@@ -3594,9 +3924,9 @@
 </p:sld>
 </file>
 
-<file path=ppt/slides/slide4.xml><?xml version="1.0" encoding="utf-8"?>
+<file path=ppt/slides/slide5.xml><?xml version="1.0" encoding="utf-8"?>
 <p:sld xmlns:a="http://schemas.openxmlformats.org/drawingml/2006/main" xmlns:r="http://schemas.openxmlformats.org/officeDocument/2006/relationships" xmlns:p="http://schemas.openxmlformats.org/presentationml/2006/main">
-  <p:cSld name="Slide 4">
+  <p:cSld name="Slide 5">
     <p:bg>
       <p:bgPr>
         <a:solidFill>
@@ -4664,7 +4994,7 @@
                 <a:ea typeface="Calibri" pitchFamily="34" charset="-122"/>
                 <a:cs typeface="Calibri" pitchFamily="34" charset="-120"/>
               </a:rPr>
-              <a:t>4</a:t>
+              <a:t>5</a:t>
             </a:r>
             <a:endParaRPr lang="en-US" sz="900" dirty="0"/>
           </a:p>
@@ -4678,9 +5008,9 @@
 </p:sld>
 </file>
 
-<file path=ppt/slides/slide5.xml><?xml version="1.0" encoding="utf-8"?>
+<file path=ppt/slides/slide6.xml><?xml version="1.0" encoding="utf-8"?>
 <p:sld xmlns:a="http://schemas.openxmlformats.org/drawingml/2006/main" xmlns:r="http://schemas.openxmlformats.org/officeDocument/2006/relationships" xmlns:p="http://schemas.openxmlformats.org/presentationml/2006/main">
-  <p:cSld name="Slide 5">
+  <p:cSld name="Slide 6">
     <p:bg>
       <p:bgPr>
         <a:solidFill>
@@ -5508,7 +5838,7 @@
                 <a:ea typeface="Calibri" pitchFamily="34" charset="-122"/>
                 <a:cs typeface="Calibri" pitchFamily="34" charset="-120"/>
               </a:rPr>
-              <a:t>5</a:t>
+              <a:t>6</a:t>
             </a:r>
             <a:endParaRPr lang="en-US" sz="900" dirty="0"/>
           </a:p>
@@ -5522,9 +5852,9 @@
 </p:sld>
 </file>
 
-<file path=ppt/slides/slide6.xml><?xml version="1.0" encoding="utf-8"?>
+<file path=ppt/slides/slide7.xml><?xml version="1.0" encoding="utf-8"?>
 <p:sld xmlns:a="http://schemas.openxmlformats.org/drawingml/2006/main" xmlns:r="http://schemas.openxmlformats.org/officeDocument/2006/relationships" xmlns:p="http://schemas.openxmlformats.org/presentationml/2006/main">
-  <p:cSld name="Slide 6">
+  <p:cSld name="Slide 7">
     <p:bg>
       <p:bgPr>
         <a:solidFill>
@@ -6315,7 +6645,7 @@
                 <a:ea typeface="Calibri" pitchFamily="34" charset="-122"/>
                 <a:cs typeface="Calibri" pitchFamily="34" charset="-120"/>
               </a:rPr>
-              <a:t>6</a:t>
+              <a:t>7</a:t>
             </a:r>
             <a:endParaRPr lang="en-US" sz="900" dirty="0"/>
           </a:p>
@@ -6329,9 +6659,9 @@
 </p:sld>
 </file>
 
-<file path=ppt/slides/slide7.xml><?xml version="1.0" encoding="utf-8"?>
+<file path=ppt/slides/slide8.xml><?xml version="1.0" encoding="utf-8"?>
 <p:sld xmlns:a="http://schemas.openxmlformats.org/drawingml/2006/main" xmlns:r="http://schemas.openxmlformats.org/officeDocument/2006/relationships" xmlns:p="http://schemas.openxmlformats.org/presentationml/2006/main">
-  <p:cSld name="Slide 7">
+  <p:cSld name="Slide 8">
     <p:bg>
       <p:bgPr>
         <a:solidFill>
@@ -6511,7 +6841,7 @@
                 <a:ea typeface="Calibri" pitchFamily="34" charset="-122"/>
                 <a:cs typeface="Calibri" pitchFamily="34" charset="-120"/>
               </a:rPr>
-              <a:t>Full source code, commit history from every team member, and this presentation.</a:t>
+              <a:t>github.com/mugisharayan/student-record-api — source code, commit history from every team member, Postman collection, and this presentation.</a:t>
             </a:r>
             <a:endParaRPr lang="en-US" sz="1200" dirty="0"/>
           </a:p>
@@ -6614,7 +6944,7 @@
                 <a:ea typeface="Calibri" pitchFamily="34" charset="-122"/>
                 <a:cs typeface="Calibri" pitchFamily="34" charset="-120"/>
               </a:rPr>
-              <a:t>Live on Render — test any endpoint directly, no local setup required.</a:t>
+              <a:t>student-record-api-w185.onrender.com — live on Render, test any endpoint directly, no local setup required.</a:t>
             </a:r>
             <a:endParaRPr lang="en-US" sz="1200" dirty="0"/>
           </a:p>
@@ -6717,7 +7047,7 @@
                 <a:ea typeface="Calibri" pitchFamily="34" charset="-122"/>
                 <a:cs typeface="Calibri" pitchFamily="34" charset="-120"/>
               </a:rPr>
-              <a:t>Import the shared collection to try every request instantly.</a:t>
+              <a:t>Import the shared collection from the repo to try every request instantly.</a:t>
             </a:r>
             <a:endParaRPr lang="en-US" sz="1200" dirty="0"/>
           </a:p>
@@ -6795,7 +7125,7 @@
                 <a:ea typeface="Calibri" pitchFamily="34" charset="-122"/>
                 <a:cs typeface="Calibri" pitchFamily="34" charset="-120"/>
               </a:rPr>
-              <a:t>7</a:t>
+              <a:t>8</a:t>
             </a:r>
             <a:endParaRPr lang="en-US" sz="900" dirty="0"/>
           </a:p>
@@ -6809,9 +7139,9 @@
 </p:sld>
 </file>
 
-<file path=ppt/slides/slide8.xml><?xml version="1.0" encoding="utf-8"?>
+<file path=ppt/slides/slide9.xml><?xml version="1.0" encoding="utf-8"?>
 <p:sld xmlns:a="http://schemas.openxmlformats.org/drawingml/2006/main" xmlns:r="http://schemas.openxmlformats.org/officeDocument/2006/relationships" xmlns:p="http://schemas.openxmlformats.org/presentationml/2006/main">
-  <p:cSld name="Slide 8">
+  <p:cSld name="Slide 9">
     <p:bg>
       <p:bgPr>
         <a:solidFill>
@@ -6942,7 +7272,7 @@
         <p:spPr>
           <a:xfrm>
             <a:off x="914400" y="1965960"/>
-            <a:ext cx="4572000" cy="2926080"/>
+            <a:ext cx="4572000" cy="3108960"/>
           </a:xfrm>
           <a:prstGeom prst="rect">
             <a:avLst/>
@@ -6956,12 +7286,12 @@
           <a:p>
             <a:pPr indent="0" marL="0">
               <a:lnSpc>
-                <a:spcPct val="180000"/>
+                <a:spcPct val="150000"/>
               </a:lnSpc>
               <a:buNone/>
             </a:pPr>
             <a:r>
-              <a:rPr lang="en-US" sz="1400" dirty="0">
+              <a:rPr lang="en-US" sz="1300" dirty="0">
                 <a:solidFill>
                   <a:srgbClr val="4A5568"/>
                 </a:solidFill>
@@ -6969,39 +7299,28 @@
                 <a:ea typeface="Calibri" pitchFamily="34" charset="-122"/>
                 <a:cs typeface="Calibri" pitchFamily="34" charset="-120"/>
               </a:rPr>
-              <a:t>• Team Member 1 — [role]</a:t>
-            </a:r>
-            <a:endParaRPr lang="en-US" sz="1400" dirty="0"/>
+              <a:t>All 14 members of BeTechified July 2026 Cohort — Backend Development, Group 2 contributed to this project as a shared effort across API development, testing, and documentation.</a:t>
+            </a:r>
+            <a:endParaRPr lang="en-US" sz="1300" dirty="0"/>
           </a:p>
           <a:p>
             <a:pPr indent="0" marL="0">
               <a:lnSpc>
-                <a:spcPct val="180000"/>
+                <a:spcPct val="150000"/>
               </a:lnSpc>
               <a:buNone/>
             </a:pPr>
-            <a:r>
-              <a:rPr lang="en-US" sz="1400" dirty="0">
-                <a:solidFill>
-                  <a:srgbClr val="4A5568"/>
-                </a:solidFill>
-                <a:latin typeface="Calibri" pitchFamily="34" charset="0"/>
-                <a:ea typeface="Calibri" pitchFamily="34" charset="-122"/>
-                <a:cs typeface="Calibri" pitchFamily="34" charset="-120"/>
-              </a:rPr>
-              <a:t>• Team Member 2 — [role]</a:t>
-            </a:r>
-            <a:endParaRPr lang="en-US" sz="1400" dirty="0"/>
+            <a:endParaRPr lang="en-US" sz="1300" dirty="0"/>
           </a:p>
           <a:p>
             <a:pPr indent="0" marL="0">
               <a:lnSpc>
-                <a:spcPct val="180000"/>
+                <a:spcPct val="150000"/>
               </a:lnSpc>
               <a:buNone/>
             </a:pPr>
             <a:r>
-              <a:rPr lang="en-US" sz="1400" dirty="0">
+              <a:rPr lang="en-US" sz="1300" dirty="0">
                 <a:solidFill>
                   <a:srgbClr val="4A5568"/>
                 </a:solidFill>
@@ -7009,29 +7328,9 @@
                 <a:ea typeface="Calibri" pitchFamily="34" charset="-122"/>
                 <a:cs typeface="Calibri" pitchFamily="34" charset="-120"/>
               </a:rPr>
-              <a:t>• Team Member 3 — [role]</a:t>
-            </a:r>
-            <a:endParaRPr lang="en-US" sz="1400" dirty="0"/>
-          </a:p>
-          <a:p>
-            <a:pPr indent="0" marL="0">
-              <a:lnSpc>
-                <a:spcPct val="180000"/>
-              </a:lnSpc>
-              <a:buNone/>
-            </a:pPr>
-            <a:r>
-              <a:rPr lang="en-US" sz="1400" dirty="0">
-                <a:solidFill>
-                  <a:srgbClr val="4A5568"/>
-                </a:solidFill>
-                <a:latin typeface="Calibri" pitchFamily="34" charset="0"/>
-                <a:ea typeface="Calibri" pitchFamily="34" charset="-122"/>
-                <a:cs typeface="Calibri" pitchFamily="34" charset="-120"/>
-              </a:rPr>
-              <a:t>• Team Member 4 — [role]</a:t>
-            </a:r>
-            <a:endParaRPr lang="en-US" sz="1400" dirty="0"/>
+              <a:t>See the "Our Team" slide for the full team photo and names.</a:t>
+            </a:r>
+            <a:endParaRPr lang="en-US" sz="1300" dirty="0"/>
           </a:p>
         </p:txBody>
       </p:sp>
@@ -7309,7 +7608,7 @@
                 <a:ea typeface="Calibri" pitchFamily="34" charset="-122"/>
                 <a:cs typeface="Calibri" pitchFamily="34" charset="-120"/>
               </a:rPr>
-              <a:t>8</a:t>
+              <a:t>9</a:t>
             </a:r>
             <a:endParaRPr lang="en-US" sz="900" dirty="0"/>
           </a:p>

</xml_diff>